<commit_message>
docs: SoPA.pptx を 9/10 版に更新（1.4MB → 3.1MB）
Co-Authored-By: Claude Fable 5.1 <noreply@anthropic.com>
Claude-Session: https://claude.ai/code/session_014c5YmuH1oc7KH3otLvgmDD
</commit_message>
<xml_diff>
--- a/docs/SoPA.pptx
+++ b/docs/SoPA.pptx
@@ -5,7 +5,7 @@
     <p:sldMasterId id="2147483648" r:id="rId1"/>
   </p:sldMasterIdLst>
   <p:notesMasterIdLst>
-    <p:notesMasterId r:id="rId16"/>
+    <p:notesMasterId r:id="rId22"/>
   </p:notesMasterIdLst>
   <p:sldIdLst>
     <p:sldId id="269" r:id="rId2"/>
@@ -22,6 +22,12 @@
     <p:sldId id="276" r:id="rId13"/>
     <p:sldId id="281" r:id="rId14"/>
     <p:sldId id="279" r:id="rId15"/>
+    <p:sldId id="287" r:id="rId16"/>
+    <p:sldId id="288" r:id="rId17"/>
+    <p:sldId id="282" r:id="rId18"/>
+    <p:sldId id="285" r:id="rId19"/>
+    <p:sldId id="284" r:id="rId20"/>
+    <p:sldId id="286" r:id="rId21"/>
   </p:sldIdLst>
   <p:sldSz cx="12192000" cy="6858000"/>
   <p:notesSz cx="6858000" cy="9144000"/>
@@ -646,6 +652,368 @@
               <a:rPr lang="en-US" altLang="ja"/>
               <a:t>6</a:t>
             </a:fld>
+            <a:endParaRPr/>
+          </a:p>
+        </p:txBody>
+      </p:sp>
+    </p:spTree>
+  </p:cSld>
+  <p:clrMapOvr>
+    <a:masterClrMapping/>
+  </p:clrMapOvr>
+</p:notes>
+</file>
+
+<file path=ppt/notesSlides/notesSlide2.xml><?xml version="1.0" encoding="utf-8"?>
+<p:notes xmlns:a="http://schemas.openxmlformats.org/drawingml/2006/main" xmlns:r="http://schemas.openxmlformats.org/officeDocument/2006/relationships" xmlns:p="http://schemas.openxmlformats.org/presentationml/2006/main" showMasterSp="0" showMasterPhAnim="0">
+  <p:cSld>
+    <p:spTree>
+      <p:nvGrpSpPr>
+        <p:cNvPr id="1" name="Shape 243"/>
+        <p:cNvGrpSpPr/>
+        <p:nvPr/>
+      </p:nvGrpSpPr>
+      <p:grpSpPr>
+        <a:xfrm>
+          <a:off x="0" y="0"/>
+          <a:ext cx="0" cy="0"/>
+          <a:chOff x="0" y="0"/>
+          <a:chExt cx="0" cy="0"/>
+        </a:xfrm>
+      </p:grpSpPr>
+      <p:sp>
+        <p:nvSpPr>
+          <p:cNvPr id="244" name="Google Shape;244;g3fabc81da82_0_21:notes"/>
+          <p:cNvSpPr>
+            <a:spLocks noGrp="1" noRot="1" noChangeAspect="1"/>
+          </p:cNvSpPr>
+          <p:nvPr>
+            <p:ph type="sldImg" idx="2"/>
+          </p:nvPr>
+        </p:nvSpPr>
+        <p:spPr>
+          <a:xfrm>
+            <a:off x="685800" y="1143000"/>
+            <a:ext cx="5486400" cy="3086100"/>
+          </a:xfrm>
+          <a:custGeom>
+            <a:avLst/>
+            <a:gdLst/>
+            <a:ahLst/>
+            <a:cxnLst/>
+            <a:rect l="l" t="t" r="r" b="b"/>
+            <a:pathLst>
+              <a:path w="120000" h="120000" extrusionOk="0">
+                <a:moveTo>
+                  <a:pt x="0" y="0"/>
+                </a:moveTo>
+                <a:lnTo>
+                  <a:pt x="120000" y="0"/>
+                </a:lnTo>
+                <a:lnTo>
+                  <a:pt x="120000" y="120000"/>
+                </a:lnTo>
+                <a:lnTo>
+                  <a:pt x="0" y="120000"/>
+                </a:lnTo>
+                <a:close/>
+              </a:path>
+            </a:pathLst>
+          </a:custGeom>
+        </p:spPr>
+      </p:sp>
+      <p:sp>
+        <p:nvSpPr>
+          <p:cNvPr id="245" name="Google Shape;245;g3fabc81da82_0_21:notes"/>
+          <p:cNvSpPr txBox="1">
+            <a:spLocks noGrp="1"/>
+          </p:cNvSpPr>
+          <p:nvPr>
+            <p:ph type="body" idx="1"/>
+          </p:nvPr>
+        </p:nvSpPr>
+        <p:spPr>
+          <a:xfrm>
+            <a:off x="685800" y="4400550"/>
+            <a:ext cx="5486400" cy="3600600"/>
+          </a:xfrm>
+          <a:prstGeom prst="rect">
+            <a:avLst/>
+          </a:prstGeom>
+        </p:spPr>
+        <p:txBody>
+          <a:bodyPr spcFirstLastPara="1" wrap="square" lIns="91425" tIns="91425" rIns="91425" bIns="91425" anchor="t" anchorCtr="0">
+            <a:noAutofit/>
+          </a:bodyPr>
+          <a:lstStyle/>
+          <a:p>
+            <a:pPr marL="0" lvl="0" indent="0" algn="l" rtl="0">
+              <a:spcBef>
+                <a:spcPts val="0"/>
+              </a:spcBef>
+              <a:spcAft>
+                <a:spcPts val="0"/>
+              </a:spcAft>
+              <a:buNone/>
+            </a:pPr>
+            <a:endParaRPr/>
+          </a:p>
+        </p:txBody>
+      </p:sp>
+      <p:sp>
+        <p:nvSpPr>
+          <p:cNvPr id="246" name="Google Shape;246;g3fabc81da82_0_21:notes"/>
+          <p:cNvSpPr txBox="1">
+            <a:spLocks noGrp="1"/>
+          </p:cNvSpPr>
+          <p:nvPr>
+            <p:ph type="sldNum" idx="12"/>
+          </p:nvPr>
+        </p:nvSpPr>
+        <p:spPr>
+          <a:xfrm>
+            <a:off x="3884613" y="8685213"/>
+            <a:ext cx="2971800" cy="458700"/>
+          </a:xfrm>
+          <a:prstGeom prst="rect">
+            <a:avLst/>
+          </a:prstGeom>
+          <a:noFill/>
+          <a:ln>
+            <a:noFill/>
+          </a:ln>
+        </p:spPr>
+        <p:txBody>
+          <a:bodyPr spcFirstLastPara="1" wrap="square" lIns="91425" tIns="91425" rIns="91425" bIns="91425" anchor="ctr" anchorCtr="0">
+            <a:noAutofit/>
+          </a:bodyPr>
+          <a:lstStyle/>
+          <a:p>
+            <a:pPr marL="0" lvl="0" indent="0" algn="l" rtl="0">
+              <a:spcBef>
+                <a:spcPts val="0"/>
+              </a:spcBef>
+              <a:spcAft>
+                <a:spcPts val="0"/>
+              </a:spcAft>
+              <a:buClr>
+                <a:srgbClr val="000000"/>
+              </a:buClr>
+              <a:buFont typeface="Arial"/>
+              <a:buNone/>
+            </a:pPr>
+            <a:fld id="{00000000-1234-1234-1234-123412341234}" type="slidenum">
+              <a:rPr lang="en-US" altLang="ja"/>
+              <a:t>18</a:t>
+            </a:fld>
+            <a:endParaRPr/>
+          </a:p>
+        </p:txBody>
+      </p:sp>
+    </p:spTree>
+  </p:cSld>
+  <p:clrMapOvr>
+    <a:masterClrMapping/>
+  </p:clrMapOvr>
+</p:notes>
+</file>
+
+<file path=ppt/notesSlides/notesSlide3.xml><?xml version="1.0" encoding="utf-8"?>
+<p:notes xmlns:a="http://schemas.openxmlformats.org/drawingml/2006/main" xmlns:r="http://schemas.openxmlformats.org/officeDocument/2006/relationships" xmlns:p="http://schemas.openxmlformats.org/presentationml/2006/main" showMasterSp="0" showMasterPhAnim="0">
+  <p:cSld>
+    <p:spTree>
+      <p:nvGrpSpPr>
+        <p:cNvPr id="1" name="Shape 279"/>
+        <p:cNvGrpSpPr/>
+        <p:nvPr/>
+      </p:nvGrpSpPr>
+      <p:grpSpPr>
+        <a:xfrm>
+          <a:off x="0" y="0"/>
+          <a:ext cx="0" cy="0"/>
+          <a:chOff x="0" y="0"/>
+          <a:chExt cx="0" cy="0"/>
+        </a:xfrm>
+      </p:grpSpPr>
+      <p:sp>
+        <p:nvSpPr>
+          <p:cNvPr id="280" name="Google Shape;280;g3f754b0405b_0_23:notes"/>
+          <p:cNvSpPr>
+            <a:spLocks noGrp="1" noRot="1" noChangeAspect="1"/>
+          </p:cNvSpPr>
+          <p:nvPr>
+            <p:ph type="sldImg" idx="2"/>
+          </p:nvPr>
+        </p:nvSpPr>
+        <p:spPr>
+          <a:xfrm>
+            <a:off x="381000" y="685800"/>
+            <a:ext cx="6096000" cy="3429000"/>
+          </a:xfrm>
+          <a:custGeom>
+            <a:avLst/>
+            <a:gdLst/>
+            <a:ahLst/>
+            <a:cxnLst/>
+            <a:rect l="l" t="t" r="r" b="b"/>
+            <a:pathLst>
+              <a:path w="120000" h="120000" extrusionOk="0">
+                <a:moveTo>
+                  <a:pt x="0" y="0"/>
+                </a:moveTo>
+                <a:lnTo>
+                  <a:pt x="120000" y="0"/>
+                </a:lnTo>
+                <a:lnTo>
+                  <a:pt x="120000" y="120000"/>
+                </a:lnTo>
+                <a:lnTo>
+                  <a:pt x="0" y="120000"/>
+                </a:lnTo>
+                <a:close/>
+              </a:path>
+            </a:pathLst>
+          </a:custGeom>
+        </p:spPr>
+      </p:sp>
+      <p:sp>
+        <p:nvSpPr>
+          <p:cNvPr id="281" name="Google Shape;281;g3f754b0405b_0_23:notes"/>
+          <p:cNvSpPr txBox="1">
+            <a:spLocks noGrp="1"/>
+          </p:cNvSpPr>
+          <p:nvPr>
+            <p:ph type="body" idx="1"/>
+          </p:nvPr>
+        </p:nvSpPr>
+        <p:spPr>
+          <a:xfrm>
+            <a:off x="685800" y="4343400"/>
+            <a:ext cx="5486400" cy="4114800"/>
+          </a:xfrm>
+          <a:prstGeom prst="rect">
+            <a:avLst/>
+          </a:prstGeom>
+        </p:spPr>
+        <p:txBody>
+          <a:bodyPr spcFirstLastPara="1" wrap="square" lIns="91425" tIns="91425" rIns="91425" bIns="91425" anchor="t" anchorCtr="0">
+            <a:noAutofit/>
+          </a:bodyPr>
+          <a:lstStyle/>
+          <a:p>
+            <a:pPr marL="0" lvl="0" indent="0" algn="l" rtl="0">
+              <a:spcBef>
+                <a:spcPts val="0"/>
+              </a:spcBef>
+              <a:spcAft>
+                <a:spcPts val="0"/>
+              </a:spcAft>
+              <a:buNone/>
+            </a:pPr>
+            <a:endParaRPr/>
+          </a:p>
+        </p:txBody>
+      </p:sp>
+    </p:spTree>
+  </p:cSld>
+  <p:clrMapOvr>
+    <a:masterClrMapping/>
+  </p:clrMapOvr>
+</p:notes>
+</file>
+
+<file path=ppt/notesSlides/notesSlide4.xml><?xml version="1.0" encoding="utf-8"?>
+<p:notes xmlns:a="http://schemas.openxmlformats.org/drawingml/2006/main" xmlns:r="http://schemas.openxmlformats.org/officeDocument/2006/relationships" xmlns:p="http://schemas.openxmlformats.org/presentationml/2006/main" showMasterSp="0" showMasterPhAnim="0">
+  <p:cSld>
+    <p:spTree>
+      <p:nvGrpSpPr>
+        <p:cNvPr id="1" name="Shape 254"/>
+        <p:cNvGrpSpPr/>
+        <p:nvPr/>
+      </p:nvGrpSpPr>
+      <p:grpSpPr>
+        <a:xfrm>
+          <a:off x="0" y="0"/>
+          <a:ext cx="0" cy="0"/>
+          <a:chOff x="0" y="0"/>
+          <a:chExt cx="0" cy="0"/>
+        </a:xfrm>
+      </p:grpSpPr>
+      <p:sp>
+        <p:nvSpPr>
+          <p:cNvPr id="255" name="Google Shape;255;g3f9ca0fcf7d_0_5:notes"/>
+          <p:cNvSpPr>
+            <a:spLocks noGrp="1" noRot="1" noChangeAspect="1"/>
+          </p:cNvSpPr>
+          <p:nvPr>
+            <p:ph type="sldImg" idx="2"/>
+          </p:nvPr>
+        </p:nvSpPr>
+        <p:spPr>
+          <a:xfrm>
+            <a:off x="381000" y="685800"/>
+            <a:ext cx="6096000" cy="3429000"/>
+          </a:xfrm>
+          <a:custGeom>
+            <a:avLst/>
+            <a:gdLst/>
+            <a:ahLst/>
+            <a:cxnLst/>
+            <a:rect l="l" t="t" r="r" b="b"/>
+            <a:pathLst>
+              <a:path w="120000" h="120000" extrusionOk="0">
+                <a:moveTo>
+                  <a:pt x="0" y="0"/>
+                </a:moveTo>
+                <a:lnTo>
+                  <a:pt x="120000" y="0"/>
+                </a:lnTo>
+                <a:lnTo>
+                  <a:pt x="120000" y="120000"/>
+                </a:lnTo>
+                <a:lnTo>
+                  <a:pt x="0" y="120000"/>
+                </a:lnTo>
+                <a:close/>
+              </a:path>
+            </a:pathLst>
+          </a:custGeom>
+        </p:spPr>
+      </p:sp>
+      <p:sp>
+        <p:nvSpPr>
+          <p:cNvPr id="256" name="Google Shape;256;g3f9ca0fcf7d_0_5:notes"/>
+          <p:cNvSpPr txBox="1">
+            <a:spLocks noGrp="1"/>
+          </p:cNvSpPr>
+          <p:nvPr>
+            <p:ph type="body" idx="1"/>
+          </p:nvPr>
+        </p:nvSpPr>
+        <p:spPr>
+          <a:xfrm>
+            <a:off x="685800" y="4343400"/>
+            <a:ext cx="5486400" cy="4114800"/>
+          </a:xfrm>
+          <a:prstGeom prst="rect">
+            <a:avLst/>
+          </a:prstGeom>
+        </p:spPr>
+        <p:txBody>
+          <a:bodyPr spcFirstLastPara="1" wrap="square" lIns="91425" tIns="91425" rIns="91425" bIns="91425" anchor="t" anchorCtr="0">
+            <a:noAutofit/>
+          </a:bodyPr>
+          <a:lstStyle/>
+          <a:p>
+            <a:pPr marL="0" lvl="0" indent="0" algn="l" rtl="0">
+              <a:spcBef>
+                <a:spcPts val="0"/>
+              </a:spcBef>
+              <a:spcAft>
+                <a:spcPts val="0"/>
+              </a:spcAft>
+              <a:buNone/>
+            </a:pPr>
             <a:endParaRPr/>
           </a:p>
         </p:txBody>
@@ -8761,6 +9129,875 @@
 </p:sld>
 </file>
 
+<file path=ppt/slides/slide15.xml><?xml version="1.0" encoding="utf-8"?>
+<p:sld xmlns:a="http://schemas.openxmlformats.org/drawingml/2006/main" xmlns:r="http://schemas.openxmlformats.org/officeDocument/2006/relationships" xmlns:p="http://schemas.openxmlformats.org/presentationml/2006/main">
+  <p:cSld>
+    <p:spTree>
+      <p:nvGrpSpPr>
+        <p:cNvPr id="1" name=""/>
+        <p:cNvGrpSpPr/>
+        <p:nvPr/>
+      </p:nvGrpSpPr>
+      <p:grpSpPr>
+        <a:xfrm>
+          <a:off x="0" y="0"/>
+          <a:ext cx="0" cy="0"/>
+          <a:chOff x="0" y="0"/>
+          <a:chExt cx="0" cy="0"/>
+        </a:xfrm>
+      </p:grpSpPr>
+      <p:sp>
+        <p:nvSpPr>
+          <p:cNvPr id="2" name="タイトル 1">
+            <a:extLst>
+              <a:ext uri="{FF2B5EF4-FFF2-40B4-BE49-F238E27FC236}">
+                <a16:creationId xmlns:a16="http://schemas.microsoft.com/office/drawing/2014/main" id="{C7E1BF66-0631-45F4-AF51-0030CE132663}"/>
+              </a:ext>
+            </a:extLst>
+          </p:cNvPr>
+          <p:cNvSpPr>
+            <a:spLocks noGrp="1"/>
+          </p:cNvSpPr>
+          <p:nvPr>
+            <p:ph type="title"/>
+          </p:nvPr>
+        </p:nvSpPr>
+        <p:spPr/>
+        <p:txBody>
+          <a:bodyPr/>
+          <a:lstStyle/>
+          <a:p>
+            <a:r>
+              <a:rPr kumimoji="1" lang="ja-JP" altLang="en-US" dirty="0"/>
+              <a:t>ネットリスト情報</a:t>
+            </a:r>
+          </a:p>
+        </p:txBody>
+      </p:sp>
+      <p:sp>
+        <p:nvSpPr>
+          <p:cNvPr id="3" name="テキスト プレースホルダー 2">
+            <a:extLst>
+              <a:ext uri="{FF2B5EF4-FFF2-40B4-BE49-F238E27FC236}">
+                <a16:creationId xmlns:a16="http://schemas.microsoft.com/office/drawing/2014/main" id="{8E0FDCA2-1749-48E2-9A35-D37608649CE2}"/>
+              </a:ext>
+            </a:extLst>
+          </p:cNvPr>
+          <p:cNvSpPr>
+            <a:spLocks noGrp="1"/>
+          </p:cNvSpPr>
+          <p:nvPr>
+            <p:ph type="body" idx="1"/>
+          </p:nvPr>
+        </p:nvSpPr>
+        <p:spPr/>
+        <p:txBody>
+          <a:bodyPr/>
+          <a:lstStyle/>
+          <a:p>
+            <a:endParaRPr kumimoji="1" lang="ja-JP" altLang="en-US"/>
+          </a:p>
+        </p:txBody>
+      </p:sp>
+    </p:spTree>
+    <p:extLst>
+      <p:ext uri="{BB962C8B-B14F-4D97-AF65-F5344CB8AC3E}">
+        <p14:creationId xmlns:p14="http://schemas.microsoft.com/office/powerpoint/2010/main" val="3964600009"/>
+      </p:ext>
+    </p:extLst>
+  </p:cSld>
+  <p:clrMapOvr>
+    <a:masterClrMapping/>
+  </p:clrMapOvr>
+</p:sld>
+</file>
+
+<file path=ppt/slides/slide16.xml><?xml version="1.0" encoding="utf-8"?>
+<p:sld xmlns:a="http://schemas.openxmlformats.org/drawingml/2006/main" xmlns:r="http://schemas.openxmlformats.org/officeDocument/2006/relationships" xmlns:p="http://schemas.openxmlformats.org/presentationml/2006/main">
+  <p:cSld>
+    <p:spTree>
+      <p:nvGrpSpPr>
+        <p:cNvPr id="1" name=""/>
+        <p:cNvGrpSpPr/>
+        <p:nvPr/>
+      </p:nvGrpSpPr>
+      <p:grpSpPr>
+        <a:xfrm>
+          <a:off x="0" y="0"/>
+          <a:ext cx="0" cy="0"/>
+          <a:chOff x="0" y="0"/>
+          <a:chExt cx="0" cy="0"/>
+        </a:xfrm>
+      </p:grpSpPr>
+      <p:sp>
+        <p:nvSpPr>
+          <p:cNvPr id="2" name="タイトル 1">
+            <a:extLst>
+              <a:ext uri="{FF2B5EF4-FFF2-40B4-BE49-F238E27FC236}">
+                <a16:creationId xmlns:a16="http://schemas.microsoft.com/office/drawing/2014/main" id="{6FEEA61F-4ED5-4478-93A4-77E75F64F9A4}"/>
+              </a:ext>
+            </a:extLst>
+          </p:cNvPr>
+          <p:cNvSpPr>
+            <a:spLocks noGrp="1"/>
+          </p:cNvSpPr>
+          <p:nvPr>
+            <p:ph type="title"/>
+          </p:nvPr>
+        </p:nvSpPr>
+        <p:spPr/>
+        <p:txBody>
+          <a:bodyPr/>
+          <a:lstStyle/>
+          <a:p>
+            <a:endParaRPr kumimoji="1" lang="ja-JP" altLang="en-US"/>
+          </a:p>
+        </p:txBody>
+      </p:sp>
+      <p:pic>
+        <p:nvPicPr>
+          <p:cNvPr id="4" name="図 3">
+            <a:extLst>
+              <a:ext uri="{FF2B5EF4-FFF2-40B4-BE49-F238E27FC236}">
+                <a16:creationId xmlns:a16="http://schemas.microsoft.com/office/drawing/2014/main" id="{F8B35591-67AD-421A-95A6-EA934FC9C631}"/>
+              </a:ext>
+            </a:extLst>
+          </p:cNvPr>
+          <p:cNvPicPr>
+            <a:picLocks noChangeAspect="1"/>
+          </p:cNvPicPr>
+          <p:nvPr/>
+        </p:nvPicPr>
+        <p:blipFill>
+          <a:blip r:embed="rId2"/>
+          <a:stretch>
+            <a:fillRect/>
+          </a:stretch>
+        </p:blipFill>
+        <p:spPr>
+          <a:xfrm>
+            <a:off x="286247" y="1252227"/>
+            <a:ext cx="11179534" cy="5276700"/>
+          </a:xfrm>
+          <a:prstGeom prst="rect">
+            <a:avLst/>
+          </a:prstGeom>
+        </p:spPr>
+      </p:pic>
+    </p:spTree>
+    <p:extLst>
+      <p:ext uri="{BB962C8B-B14F-4D97-AF65-F5344CB8AC3E}">
+        <p14:creationId xmlns:p14="http://schemas.microsoft.com/office/powerpoint/2010/main" val="1033662271"/>
+      </p:ext>
+    </p:extLst>
+  </p:cSld>
+  <p:clrMapOvr>
+    <a:masterClrMapping/>
+  </p:clrMapOvr>
+</p:sld>
+</file>
+
+<file path=ppt/slides/slide17.xml><?xml version="1.0" encoding="utf-8"?>
+<p:sld xmlns:a="http://schemas.openxmlformats.org/drawingml/2006/main" xmlns:r="http://schemas.openxmlformats.org/officeDocument/2006/relationships" xmlns:p="http://schemas.openxmlformats.org/presentationml/2006/main">
+  <p:cSld>
+    <p:spTree>
+      <p:nvGrpSpPr>
+        <p:cNvPr id="1" name=""/>
+        <p:cNvGrpSpPr/>
+        <p:nvPr/>
+      </p:nvGrpSpPr>
+      <p:grpSpPr>
+        <a:xfrm>
+          <a:off x="0" y="0"/>
+          <a:ext cx="0" cy="0"/>
+          <a:chOff x="0" y="0"/>
+          <a:chExt cx="0" cy="0"/>
+        </a:xfrm>
+      </p:grpSpPr>
+      <p:sp>
+        <p:nvSpPr>
+          <p:cNvPr id="2" name="タイトル 1">
+            <a:extLst>
+              <a:ext uri="{FF2B5EF4-FFF2-40B4-BE49-F238E27FC236}">
+                <a16:creationId xmlns:a16="http://schemas.microsoft.com/office/drawing/2014/main" id="{C4A178BC-81E9-4668-9F79-488C1276F488}"/>
+              </a:ext>
+            </a:extLst>
+          </p:cNvPr>
+          <p:cNvSpPr>
+            <a:spLocks noGrp="1"/>
+          </p:cNvSpPr>
+          <p:nvPr>
+            <p:ph type="title"/>
+          </p:nvPr>
+        </p:nvSpPr>
+        <p:spPr/>
+        <p:txBody>
+          <a:bodyPr/>
+          <a:lstStyle/>
+          <a:p>
+            <a:r>
+              <a:rPr kumimoji="1" lang="ja-JP" altLang="en-US" dirty="0"/>
+              <a:t>配置配線結果</a:t>
+            </a:r>
+          </a:p>
+        </p:txBody>
+      </p:sp>
+      <p:sp>
+        <p:nvSpPr>
+          <p:cNvPr id="3" name="テキスト プレースホルダー 2">
+            <a:extLst>
+              <a:ext uri="{FF2B5EF4-FFF2-40B4-BE49-F238E27FC236}">
+                <a16:creationId xmlns:a16="http://schemas.microsoft.com/office/drawing/2014/main" id="{67BC8974-3204-4D78-A333-ECBFB736A22D}"/>
+              </a:ext>
+            </a:extLst>
+          </p:cNvPr>
+          <p:cNvSpPr>
+            <a:spLocks noGrp="1"/>
+          </p:cNvSpPr>
+          <p:nvPr>
+            <p:ph type="body" idx="1"/>
+          </p:nvPr>
+        </p:nvSpPr>
+        <p:spPr/>
+        <p:txBody>
+          <a:bodyPr/>
+          <a:lstStyle/>
+          <a:p>
+            <a:endParaRPr kumimoji="1" lang="ja-JP" altLang="en-US"/>
+          </a:p>
+        </p:txBody>
+      </p:sp>
+    </p:spTree>
+    <p:extLst>
+      <p:ext uri="{BB962C8B-B14F-4D97-AF65-F5344CB8AC3E}">
+        <p14:creationId xmlns:p14="http://schemas.microsoft.com/office/powerpoint/2010/main" val="2603611837"/>
+      </p:ext>
+    </p:extLst>
+  </p:cSld>
+  <p:clrMapOvr>
+    <a:masterClrMapping/>
+  </p:clrMapOvr>
+</p:sld>
+</file>
+
+<file path=ppt/slides/slide18.xml><?xml version="1.0" encoding="utf-8"?>
+<p:sld xmlns:a="http://schemas.openxmlformats.org/drawingml/2006/main" xmlns:r="http://schemas.openxmlformats.org/officeDocument/2006/relationships" xmlns:p="http://schemas.openxmlformats.org/presentationml/2006/main">
+  <p:cSld>
+    <p:spTree>
+      <p:nvGrpSpPr>
+        <p:cNvPr id="1" name="Shape 247"/>
+        <p:cNvGrpSpPr/>
+        <p:nvPr/>
+      </p:nvGrpSpPr>
+      <p:grpSpPr>
+        <a:xfrm>
+          <a:off x="0" y="0"/>
+          <a:ext cx="0" cy="0"/>
+          <a:chOff x="0" y="0"/>
+          <a:chExt cx="0" cy="0"/>
+        </a:xfrm>
+      </p:grpSpPr>
+      <p:sp>
+        <p:nvSpPr>
+          <p:cNvPr id="248" name="Google Shape;248;p26"/>
+          <p:cNvSpPr txBox="1">
+            <a:spLocks noGrp="1"/>
+          </p:cNvSpPr>
+          <p:nvPr>
+            <p:ph type="title"/>
+          </p:nvPr>
+        </p:nvSpPr>
+        <p:spPr>
+          <a:xfrm>
+            <a:off x="144780" y="167005"/>
+            <a:ext cx="12047220" cy="732400"/>
+          </a:xfrm>
+          <a:prstGeom prst="rect">
+            <a:avLst/>
+          </a:prstGeom>
+        </p:spPr>
+        <p:txBody>
+          <a:bodyPr spcFirstLastPara="1" vert="horz" wrap="square" lIns="91433" tIns="45700" rIns="91433" bIns="45700" rtlCol="0" anchor="ctr" anchorCtr="0">
+            <a:normAutofit/>
+          </a:bodyPr>
+          <a:lstStyle/>
+          <a:p>
+            <a:r>
+              <a:rPr lang="ja" dirty="0"/>
+              <a:t>配線構造を作成</a:t>
+            </a:r>
+            <a:r>
+              <a:rPr lang="en-US" altLang="ja" sz="2800" dirty="0"/>
+              <a:t>(41</a:t>
+            </a:r>
+            <a:r>
+              <a:rPr lang="ja-JP" altLang="en-US" sz="2800" dirty="0"/>
+              <a:t>回路それぞれで最小構造を作成</a:t>
+            </a:r>
+            <a:r>
+              <a:rPr lang="en-US" altLang="ja" sz="2800" dirty="0"/>
+              <a:t>)</a:t>
+            </a:r>
+            <a:endParaRPr dirty="0"/>
+          </a:p>
+        </p:txBody>
+      </p:sp>
+      <p:sp>
+        <p:nvSpPr>
+          <p:cNvPr id="249" name="Google Shape;249;p26"/>
+          <p:cNvSpPr txBox="1">
+            <a:spLocks noGrp="1"/>
+          </p:cNvSpPr>
+          <p:nvPr>
+            <p:ph type="body" idx="1"/>
+          </p:nvPr>
+        </p:nvSpPr>
+        <p:spPr>
+          <a:xfrm>
+            <a:off x="8170467" y="1774367"/>
+            <a:ext cx="3844400" cy="3725600"/>
+          </a:xfrm>
+          <a:prstGeom prst="rect">
+            <a:avLst/>
+          </a:prstGeom>
+        </p:spPr>
+        <p:txBody>
+          <a:bodyPr spcFirstLastPara="1" vert="horz" wrap="square" lIns="91433" tIns="45700" rIns="91433" bIns="45700" rtlCol="0" anchor="t" anchorCtr="0">
+            <a:normAutofit/>
+          </a:bodyPr>
+          <a:lstStyle/>
+          <a:p>
+            <a:pPr marL="0" indent="0">
+              <a:buNone/>
+            </a:pPr>
+            <a:r>
+              <a:rPr lang="ja" altLang="en-US" sz="2400">
+                <a:solidFill>
+                  <a:schemeClr val="dk1"/>
+                </a:solidFill>
+              </a:rPr>
+              <a:t>ネットリストと同じ構成で配線構造を準備</a:t>
+            </a:r>
+            <a:endParaRPr sz="2400">
+              <a:solidFill>
+                <a:schemeClr val="dk1"/>
+              </a:solidFill>
+            </a:endParaRPr>
+          </a:p>
+          <a:p>
+            <a:pPr marL="0" indent="0">
+              <a:spcBef>
+                <a:spcPts val="1600"/>
+              </a:spcBef>
+              <a:buNone/>
+            </a:pPr>
+            <a:endParaRPr sz="2400">
+              <a:solidFill>
+                <a:schemeClr val="dk1"/>
+              </a:solidFill>
+            </a:endParaRPr>
+          </a:p>
+          <a:p>
+            <a:pPr marL="0" indent="0">
+              <a:spcBef>
+                <a:spcPts val="1600"/>
+              </a:spcBef>
+              <a:buNone/>
+            </a:pPr>
+            <a:endParaRPr sz="2400">
+              <a:solidFill>
+                <a:schemeClr val="dk1"/>
+              </a:solidFill>
+            </a:endParaRPr>
+          </a:p>
+          <a:p>
+            <a:pPr marL="0" indent="0">
+              <a:spcBef>
+                <a:spcPts val="1600"/>
+              </a:spcBef>
+              <a:spcAft>
+                <a:spcPts val="1600"/>
+              </a:spcAft>
+              <a:buNone/>
+            </a:pPr>
+            <a:r>
+              <a:rPr lang="ja" altLang="en-US" sz="2400">
+                <a:solidFill>
+                  <a:schemeClr val="dk1"/>
+                </a:solidFill>
+              </a:rPr>
+              <a:t>この構造は配置可能箇所数が最小</a:t>
+            </a:r>
+            <a:endParaRPr sz="2400">
+              <a:solidFill>
+                <a:schemeClr val="dk1"/>
+              </a:solidFill>
+            </a:endParaRPr>
+          </a:p>
+        </p:txBody>
+      </p:sp>
+      <p:pic>
+        <p:nvPicPr>
+          <p:cNvPr id="250" name="Google Shape;250;p26"/>
+          <p:cNvPicPr preferRelativeResize="0"/>
+          <p:nvPr/>
+        </p:nvPicPr>
+        <p:blipFill>
+          <a:blip r:embed="rId3">
+            <a:alphaModFix/>
+          </a:blip>
+          <a:stretch>
+            <a:fillRect/>
+          </a:stretch>
+        </p:blipFill>
+        <p:spPr>
+          <a:xfrm>
+            <a:off x="44301" y="1155075"/>
+            <a:ext cx="4572801" cy="4317304"/>
+          </a:xfrm>
+          <a:prstGeom prst="rect">
+            <a:avLst/>
+          </a:prstGeom>
+          <a:noFill/>
+          <a:ln>
+            <a:noFill/>
+          </a:ln>
+        </p:spPr>
+      </p:pic>
+      <p:sp>
+        <p:nvSpPr>
+          <p:cNvPr id="251" name="Google Shape;251;p26"/>
+          <p:cNvSpPr/>
+          <p:nvPr/>
+        </p:nvSpPr>
+        <p:spPr>
+          <a:xfrm>
+            <a:off x="5115512" y="3004475"/>
+            <a:ext cx="319600" cy="732400"/>
+          </a:xfrm>
+          <a:prstGeom prst="rightArrow">
+            <a:avLst>
+              <a:gd name="adj1" fmla="val 50000"/>
+              <a:gd name="adj2" fmla="val 50000"/>
+            </a:avLst>
+          </a:prstGeom>
+          <a:solidFill>
+            <a:schemeClr val="lt2"/>
+          </a:solidFill>
+          <a:ln w="7150" cap="flat" cmpd="sng">
+            <a:solidFill>
+              <a:schemeClr val="dk2"/>
+            </a:solidFill>
+            <a:prstDash val="solid"/>
+            <a:round/>
+            <a:headEnd type="none" w="sm" len="sm"/>
+            <a:tailEnd type="none" w="sm" len="sm"/>
+          </a:ln>
+        </p:spPr>
+        <p:txBody>
+          <a:bodyPr spcFirstLastPara="1" wrap="square" lIns="91433" tIns="91433" rIns="91433" bIns="91433" anchor="ctr" anchorCtr="0">
+            <a:noAutofit/>
+          </a:bodyPr>
+          <a:lstStyle/>
+          <a:p>
+            <a:pPr algn="ctr"/>
+            <a:endParaRPr sz="1467">
+              <a:latin typeface="Meiryo"/>
+              <a:ea typeface="Meiryo"/>
+              <a:cs typeface="Meiryo"/>
+              <a:sym typeface="Meiryo"/>
+            </a:endParaRPr>
+          </a:p>
+        </p:txBody>
+      </p:sp>
+      <p:sp>
+        <p:nvSpPr>
+          <p:cNvPr id="252" name="Google Shape;252;p26"/>
+          <p:cNvSpPr txBox="1">
+            <a:spLocks noGrp="1"/>
+          </p:cNvSpPr>
+          <p:nvPr>
+            <p:ph type="body" idx="1"/>
+          </p:nvPr>
+        </p:nvSpPr>
+        <p:spPr>
+          <a:xfrm>
+            <a:off x="1268700" y="6058884"/>
+            <a:ext cx="2730400" cy="507200"/>
+          </a:xfrm>
+          <a:prstGeom prst="rect">
+            <a:avLst/>
+          </a:prstGeom>
+        </p:spPr>
+        <p:txBody>
+          <a:bodyPr spcFirstLastPara="1" vert="horz" wrap="square" lIns="91433" tIns="45700" rIns="91433" bIns="45700" rtlCol="0" anchor="t" anchorCtr="0">
+            <a:normAutofit fontScale="25000" lnSpcReduction="20000"/>
+          </a:bodyPr>
+          <a:lstStyle/>
+          <a:p>
+            <a:pPr marL="0" indent="0">
+              <a:spcAft>
+                <a:spcPts val="1600"/>
+              </a:spcAft>
+              <a:buNone/>
+            </a:pPr>
+            <a:r>
+              <a:rPr lang="ja"/>
+              <a:t>回路ネットリスト</a:t>
+            </a:r>
+            <a:endParaRPr/>
+          </a:p>
+        </p:txBody>
+      </p:sp>
+      <p:sp>
+        <p:nvSpPr>
+          <p:cNvPr id="253" name="Google Shape;253;p26"/>
+          <p:cNvSpPr txBox="1">
+            <a:spLocks noGrp="1"/>
+          </p:cNvSpPr>
+          <p:nvPr>
+            <p:ph type="body" idx="1"/>
+          </p:nvPr>
+        </p:nvSpPr>
+        <p:spPr>
+          <a:xfrm>
+            <a:off x="5854225" y="6081084"/>
+            <a:ext cx="1801200" cy="462800"/>
+          </a:xfrm>
+          <a:prstGeom prst="rect">
+            <a:avLst/>
+          </a:prstGeom>
+        </p:spPr>
+        <p:txBody>
+          <a:bodyPr spcFirstLastPara="1" vert="horz" wrap="square" lIns="91433" tIns="45700" rIns="91433" bIns="45700" rtlCol="0" anchor="t" anchorCtr="0">
+            <a:normAutofit fontScale="25000" lnSpcReduction="20000"/>
+          </a:bodyPr>
+          <a:lstStyle/>
+          <a:p>
+            <a:pPr marL="0" indent="0">
+              <a:lnSpc>
+                <a:spcPct val="70000"/>
+              </a:lnSpc>
+              <a:spcAft>
+                <a:spcPts val="1600"/>
+              </a:spcAft>
+              <a:buNone/>
+            </a:pPr>
+            <a:r>
+              <a:rPr lang="ja" altLang="en-US" sz="2400"/>
+              <a:t>配線構造</a:t>
+            </a:r>
+            <a:endParaRPr sz="2400"/>
+          </a:p>
+        </p:txBody>
+      </p:sp>
+      <p:pic>
+        <p:nvPicPr>
+          <p:cNvPr id="254" name="Google Shape;254;p26"/>
+          <p:cNvPicPr preferRelativeResize="0"/>
+          <p:nvPr/>
+        </p:nvPicPr>
+        <p:blipFill>
+          <a:blip r:embed="rId4">
+            <a:alphaModFix/>
+          </a:blip>
+          <a:stretch>
+            <a:fillRect/>
+          </a:stretch>
+        </p:blipFill>
+        <p:spPr>
+          <a:xfrm>
+            <a:off x="5597354" y="1080761"/>
+            <a:ext cx="1801201" cy="4818971"/>
+          </a:xfrm>
+          <a:prstGeom prst="rect">
+            <a:avLst/>
+          </a:prstGeom>
+          <a:noFill/>
+          <a:ln>
+            <a:noFill/>
+          </a:ln>
+        </p:spPr>
+      </p:pic>
+      <p:sp>
+        <p:nvSpPr>
+          <p:cNvPr id="255" name="Google Shape;255;p26"/>
+          <p:cNvSpPr txBox="1">
+            <a:spLocks noGrp="1"/>
+          </p:cNvSpPr>
+          <p:nvPr>
+            <p:ph type="sldNum" idx="12"/>
+          </p:nvPr>
+        </p:nvSpPr>
+        <p:spPr>
+          <a:xfrm>
+            <a:off x="9250680" y="6334760"/>
+            <a:ext cx="2743200" cy="365200"/>
+          </a:xfrm>
+          <a:prstGeom prst="rect">
+            <a:avLst/>
+          </a:prstGeom>
+        </p:spPr>
+        <p:txBody>
+          <a:bodyPr spcFirstLastPara="1" vert="horz" wrap="square" lIns="91433" tIns="45700" rIns="91433" bIns="45700" rtlCol="0" anchor="ctr" anchorCtr="0">
+            <a:normAutofit/>
+          </a:bodyPr>
+          <a:lstStyle/>
+          <a:p>
+            <a:pPr>
+              <a:buClr>
+                <a:srgbClr val="000000"/>
+              </a:buClr>
+            </a:pPr>
+            <a:fld id="{00000000-1234-1234-1234-123412341234}" type="slidenum">
+              <a:rPr lang="en-US" altLang="ja"/>
+              <a:pPr>
+                <a:buClr>
+                  <a:srgbClr val="000000"/>
+                </a:buClr>
+              </a:pPr>
+              <a:t>18</a:t>
+            </a:fld>
+            <a:endParaRPr/>
+          </a:p>
+        </p:txBody>
+      </p:sp>
+    </p:spTree>
+  </p:cSld>
+  <p:clrMapOvr>
+    <a:masterClrMapping/>
+  </p:clrMapOvr>
+</p:sld>
+</file>
+
+<file path=ppt/slides/slide19.xml><?xml version="1.0" encoding="utf-8"?>
+<p:sld xmlns:a="http://schemas.openxmlformats.org/drawingml/2006/main" xmlns:r="http://schemas.openxmlformats.org/officeDocument/2006/relationships" xmlns:p="http://schemas.openxmlformats.org/presentationml/2006/main">
+  <p:cSld>
+    <p:spTree>
+      <p:nvGrpSpPr>
+        <p:cNvPr id="1" name="Shape 282"/>
+        <p:cNvGrpSpPr/>
+        <p:nvPr/>
+      </p:nvGrpSpPr>
+      <p:grpSpPr>
+        <a:xfrm>
+          <a:off x="0" y="0"/>
+          <a:ext cx="0" cy="0"/>
+          <a:chOff x="0" y="0"/>
+          <a:chExt cx="0" cy="0"/>
+        </a:xfrm>
+      </p:grpSpPr>
+      <p:sp>
+        <p:nvSpPr>
+          <p:cNvPr id="283" name="Google Shape;283;p28"/>
+          <p:cNvSpPr txBox="1">
+            <a:spLocks noGrp="1"/>
+          </p:cNvSpPr>
+          <p:nvPr>
+            <p:ph type="title"/>
+          </p:nvPr>
+        </p:nvSpPr>
+        <p:spPr>
+          <a:xfrm>
+            <a:off x="144780" y="167005"/>
+            <a:ext cx="10397600" cy="732400"/>
+          </a:xfrm>
+          <a:prstGeom prst="rect">
+            <a:avLst/>
+          </a:prstGeom>
+        </p:spPr>
+        <p:txBody>
+          <a:bodyPr spcFirstLastPara="1" vert="horz" wrap="square" lIns="91433" tIns="45700" rIns="91433" bIns="45700" rtlCol="0" anchor="ctr" anchorCtr="0">
+            <a:normAutofit/>
+          </a:bodyPr>
+          <a:lstStyle/>
+          <a:p>
+            <a:r>
+              <a:rPr lang="ja" dirty="0"/>
+              <a:t>結果</a:t>
+            </a:r>
+            <a:endParaRPr dirty="0"/>
+          </a:p>
+        </p:txBody>
+      </p:sp>
+      <p:pic>
+        <p:nvPicPr>
+          <p:cNvPr id="284" name="Google Shape;284;p28"/>
+          <p:cNvPicPr preferRelativeResize="0"/>
+          <p:nvPr/>
+        </p:nvPicPr>
+        <p:blipFill rotWithShape="1">
+          <a:blip r:embed="rId3">
+            <a:alphaModFix/>
+          </a:blip>
+          <a:srcRect l="478" t="606"/>
+          <a:stretch/>
+        </p:blipFill>
+        <p:spPr>
+          <a:xfrm>
+            <a:off x="227700" y="1339667"/>
+            <a:ext cx="8146931" cy="5404832"/>
+          </a:xfrm>
+          <a:prstGeom prst="rect">
+            <a:avLst/>
+          </a:prstGeom>
+          <a:noFill/>
+          <a:ln>
+            <a:noFill/>
+          </a:ln>
+        </p:spPr>
+      </p:pic>
+      <p:pic>
+        <p:nvPicPr>
+          <p:cNvPr id="285" name="Google Shape;285;p28"/>
+          <p:cNvPicPr preferRelativeResize="0"/>
+          <p:nvPr/>
+        </p:nvPicPr>
+        <p:blipFill>
+          <a:blip r:embed="rId4">
+            <a:alphaModFix/>
+          </a:blip>
+          <a:stretch>
+            <a:fillRect/>
+          </a:stretch>
+        </p:blipFill>
+        <p:spPr>
+          <a:xfrm>
+            <a:off x="7659667" y="94334"/>
+            <a:ext cx="4421068" cy="2477465"/>
+          </a:xfrm>
+          <a:prstGeom prst="rect">
+            <a:avLst/>
+          </a:prstGeom>
+          <a:noFill/>
+          <a:ln>
+            <a:noFill/>
+          </a:ln>
+        </p:spPr>
+      </p:pic>
+      <p:sp>
+        <p:nvSpPr>
+          <p:cNvPr id="286" name="Google Shape;286;p28"/>
+          <p:cNvSpPr txBox="1"/>
+          <p:nvPr/>
+        </p:nvSpPr>
+        <p:spPr>
+          <a:xfrm>
+            <a:off x="8450567" y="3883567"/>
+            <a:ext cx="3582400" cy="1263200"/>
+          </a:xfrm>
+          <a:prstGeom prst="rect">
+            <a:avLst/>
+          </a:prstGeom>
+          <a:noFill/>
+          <a:ln>
+            <a:noFill/>
+          </a:ln>
+        </p:spPr>
+        <p:txBody>
+          <a:bodyPr spcFirstLastPara="1" wrap="square" lIns="121900" tIns="121900" rIns="121900" bIns="121900" anchor="t" anchorCtr="0">
+            <a:noAutofit/>
+          </a:bodyPr>
+          <a:lstStyle/>
+          <a:p>
+            <a:r>
+              <a:rPr lang="ja" altLang="en-US" sz="2400">
+                <a:solidFill>
+                  <a:schemeClr val="dk1"/>
+                </a:solidFill>
+              </a:rPr>
+              <a:t>回路規模が大きくなるほど</a:t>
+            </a:r>
+            <a:r>
+              <a:rPr lang="en-US" altLang="ja" sz="2400">
+                <a:solidFill>
+                  <a:schemeClr val="dk1"/>
+                </a:solidFill>
+              </a:rPr>
+              <a:t>SoPA</a:t>
+            </a:r>
+            <a:r>
+              <a:rPr lang="ja" altLang="en-US" sz="2400">
+                <a:solidFill>
+                  <a:schemeClr val="dk1"/>
+                </a:solidFill>
+              </a:rPr>
+              <a:t>の優位性は</a:t>
+            </a:r>
+            <a:endParaRPr sz="2400">
+              <a:solidFill>
+                <a:schemeClr val="dk1"/>
+              </a:solidFill>
+            </a:endParaRPr>
+          </a:p>
+          <a:p>
+            <a:r>
+              <a:rPr lang="ja" altLang="en-US" sz="2400">
+                <a:solidFill>
+                  <a:schemeClr val="dk1"/>
+                </a:solidFill>
+              </a:rPr>
+              <a:t>小さくなる</a:t>
+            </a:r>
+            <a:endParaRPr sz="2400">
+              <a:solidFill>
+                <a:schemeClr val="dk1"/>
+              </a:solidFill>
+            </a:endParaRPr>
+          </a:p>
+        </p:txBody>
+      </p:sp>
+      <p:sp>
+        <p:nvSpPr>
+          <p:cNvPr id="287" name="Google Shape;287;p28"/>
+          <p:cNvSpPr txBox="1">
+            <a:spLocks noGrp="1"/>
+          </p:cNvSpPr>
+          <p:nvPr>
+            <p:ph type="sldNum" idx="12"/>
+          </p:nvPr>
+        </p:nvSpPr>
+        <p:spPr>
+          <a:xfrm>
+            <a:off x="9250680" y="6334760"/>
+            <a:ext cx="2743200" cy="365200"/>
+          </a:xfrm>
+          <a:prstGeom prst="rect">
+            <a:avLst/>
+          </a:prstGeom>
+        </p:spPr>
+        <p:txBody>
+          <a:bodyPr spcFirstLastPara="1" vert="horz" wrap="square" lIns="91433" tIns="45700" rIns="91433" bIns="45700" rtlCol="0" anchor="ctr" anchorCtr="0">
+            <a:normAutofit/>
+          </a:bodyPr>
+          <a:lstStyle/>
+          <a:p>
+            <a:pPr>
+              <a:buClr>
+                <a:srgbClr val="000000"/>
+              </a:buClr>
+            </a:pPr>
+            <a:fld id="{00000000-1234-1234-1234-123412341234}" type="slidenum">
+              <a:rPr lang="en-US" altLang="ja"/>
+              <a:pPr>
+                <a:buClr>
+                  <a:srgbClr val="000000"/>
+                </a:buClr>
+              </a:pPr>
+              <a:t>19</a:t>
+            </a:fld>
+            <a:endParaRPr/>
+          </a:p>
+        </p:txBody>
+      </p:sp>
+    </p:spTree>
+  </p:cSld>
+  <p:clrMapOvr>
+    <a:masterClrMapping/>
+  </p:clrMapOvr>
+</p:sld>
+</file>
+
 <file path=ppt/slides/slide2.xml><?xml version="1.0" encoding="utf-8"?>
 <p:sld xmlns:a="http://schemas.openxmlformats.org/drawingml/2006/main" xmlns:r="http://schemas.openxmlformats.org/officeDocument/2006/relationships" xmlns:p="http://schemas.openxmlformats.org/presentationml/2006/main">
   <p:cSld>
@@ -8837,6 +10074,175 @@
         <p14:creationId xmlns:p14="http://schemas.microsoft.com/office/powerpoint/2010/main" val="2524028814"/>
       </p:ext>
     </p:extLst>
+  </p:cSld>
+  <p:clrMapOvr>
+    <a:masterClrMapping/>
+  </p:clrMapOvr>
+</p:sld>
+</file>
+
+<file path=ppt/slides/slide20.xml><?xml version="1.0" encoding="utf-8"?>
+<p:sld xmlns:a="http://schemas.openxmlformats.org/drawingml/2006/main" xmlns:r="http://schemas.openxmlformats.org/officeDocument/2006/relationships" xmlns:p="http://schemas.openxmlformats.org/presentationml/2006/main">
+  <p:cSld>
+    <p:spTree>
+      <p:nvGrpSpPr>
+        <p:cNvPr id="1" name="Shape 257"/>
+        <p:cNvGrpSpPr/>
+        <p:nvPr/>
+      </p:nvGrpSpPr>
+      <p:grpSpPr>
+        <a:xfrm>
+          <a:off x="0" y="0"/>
+          <a:ext cx="0" cy="0"/>
+          <a:chOff x="0" y="0"/>
+          <a:chExt cx="0" cy="0"/>
+        </a:xfrm>
+      </p:grpSpPr>
+      <p:sp>
+        <p:nvSpPr>
+          <p:cNvPr id="258" name="Google Shape;258;p26"/>
+          <p:cNvSpPr txBox="1">
+            <a:spLocks noGrp="1"/>
+          </p:cNvSpPr>
+          <p:nvPr>
+            <p:ph type="title"/>
+          </p:nvPr>
+        </p:nvSpPr>
+        <p:spPr>
+          <a:xfrm>
+            <a:off x="144780" y="167005"/>
+            <a:ext cx="10397600" cy="732400"/>
+          </a:xfrm>
+          <a:prstGeom prst="rect">
+            <a:avLst/>
+          </a:prstGeom>
+        </p:spPr>
+        <p:txBody>
+          <a:bodyPr spcFirstLastPara="1" vert="horz" wrap="square" lIns="91433" tIns="45700" rIns="91433" bIns="45700" rtlCol="0" anchor="ctr" anchorCtr="0">
+            <a:normAutofit/>
+          </a:bodyPr>
+          <a:lstStyle/>
+          <a:p>
+            <a:r>
+              <a:rPr lang="ja-JP" altLang="en-US" dirty="0"/>
+              <a:t>面積比較</a:t>
+            </a:r>
+            <a:r>
+              <a:rPr lang="en-US" altLang="ja-JP" sz="3200" dirty="0"/>
+              <a:t>(</a:t>
+            </a:r>
+            <a:r>
+              <a:rPr lang="ja-JP" altLang="en-US" sz="3200" dirty="0"/>
+              <a:t>面積は規模拡大でも優位性を保つ</a:t>
+            </a:r>
+            <a:r>
+              <a:rPr lang="en-US" altLang="ja-JP" sz="3200" dirty="0"/>
+              <a:t>)</a:t>
+            </a:r>
+            <a:endParaRPr dirty="0"/>
+          </a:p>
+        </p:txBody>
+      </p:sp>
+      <p:sp>
+        <p:nvSpPr>
+          <p:cNvPr id="259" name="Google Shape;259;p26"/>
+          <p:cNvSpPr txBox="1">
+            <a:spLocks noGrp="1"/>
+          </p:cNvSpPr>
+          <p:nvPr>
+            <p:ph type="sldNum" idx="12"/>
+          </p:nvPr>
+        </p:nvSpPr>
+        <p:spPr>
+          <a:xfrm>
+            <a:off x="9250680" y="6334760"/>
+            <a:ext cx="2743200" cy="365200"/>
+          </a:xfrm>
+          <a:prstGeom prst="rect">
+            <a:avLst/>
+          </a:prstGeom>
+        </p:spPr>
+        <p:txBody>
+          <a:bodyPr spcFirstLastPara="1" vert="horz" wrap="square" lIns="91433" tIns="45700" rIns="91433" bIns="45700" rtlCol="0" anchor="ctr" anchorCtr="0">
+            <a:normAutofit/>
+          </a:bodyPr>
+          <a:lstStyle/>
+          <a:p>
+            <a:pPr>
+              <a:buClr>
+                <a:srgbClr val="000000"/>
+              </a:buClr>
+            </a:pPr>
+            <a:fld id="{00000000-1234-1234-1234-123412341234}" type="slidenum">
+              <a:rPr lang="en-US" altLang="ja"/>
+              <a:pPr>
+                <a:buClr>
+                  <a:srgbClr val="000000"/>
+                </a:buClr>
+              </a:pPr>
+              <a:t>20</a:t>
+            </a:fld>
+            <a:endParaRPr/>
+          </a:p>
+        </p:txBody>
+      </p:sp>
+      <p:pic>
+        <p:nvPicPr>
+          <p:cNvPr id="260" name="Google Shape;260;p26"/>
+          <p:cNvPicPr preferRelativeResize="0"/>
+          <p:nvPr/>
+        </p:nvPicPr>
+        <p:blipFill>
+          <a:blip r:embed="rId3">
+            <a:alphaModFix/>
+          </a:blip>
+          <a:stretch>
+            <a:fillRect/>
+          </a:stretch>
+        </p:blipFill>
+        <p:spPr>
+          <a:xfrm>
+            <a:off x="4458500" y="3429001"/>
+            <a:ext cx="5944003" cy="3270967"/>
+          </a:xfrm>
+          <a:prstGeom prst="rect">
+            <a:avLst/>
+          </a:prstGeom>
+          <a:noFill/>
+          <a:ln>
+            <a:noFill/>
+          </a:ln>
+        </p:spPr>
+      </p:pic>
+      <p:pic>
+        <p:nvPicPr>
+          <p:cNvPr id="261" name="Google Shape;261;p26"/>
+          <p:cNvPicPr preferRelativeResize="0"/>
+          <p:nvPr/>
+        </p:nvPicPr>
+        <p:blipFill>
+          <a:blip r:embed="rId4">
+            <a:alphaModFix/>
+          </a:blip>
+          <a:stretch>
+            <a:fillRect/>
+          </a:stretch>
+        </p:blipFill>
+        <p:spPr>
+          <a:xfrm>
+            <a:off x="144768" y="1073201"/>
+            <a:ext cx="12047233" cy="2327828"/>
+          </a:xfrm>
+          <a:prstGeom prst="rect">
+            <a:avLst/>
+          </a:prstGeom>
+          <a:noFill/>
+          <a:ln>
+            <a:noFill/>
+          </a:ln>
+        </p:spPr>
+      </p:pic>
+    </p:spTree>
   </p:cSld>
   <p:clrMapOvr>
     <a:masterClrMapping/>

</xml_diff>